<commit_message>
Address provider session review feedback
</commit_message>
<xml_diff>
--- a/docs/lessons/assets/cah-021-one-model-turn.pptx
+++ b/docs/lessons/assets/cah-021-one-model-turn.pptx
@@ -2,22 +2,22 @@
 <file path=ppt/presentation.xml><?xml version="1.0" encoding="utf-8"?>
 <p:presentation xmlns:p="http://schemas.openxmlformats.org/presentationml/2006/main">
   <p:sldMasterIdLst>
-    <p:sldMasterId xmlns:r="http://schemas.openxmlformats.org/officeDocument/2006/relationships" id="2147483648" r:id="R29df461247564f2b"/>
+    <p:sldMasterId xmlns:r="http://schemas.openxmlformats.org/officeDocument/2006/relationships" id="2147483648" r:id="R0a6a4c18af444bd5"/>
   </p:sldMasterIdLst>
   <p:notesMasterIdLst>
-    <p:notesMasterId xmlns:r="http://schemas.openxmlformats.org/officeDocument/2006/relationships" r:id="R4f8a6eed9ea54e89"/>
+    <p:notesMasterId xmlns:r="http://schemas.openxmlformats.org/officeDocument/2006/relationships" r:id="Rffe6ddcb3d15446e"/>
   </p:notesMasterIdLst>
   <p:sldIdLst>
-    <p:sldId xmlns:r="http://schemas.openxmlformats.org/officeDocument/2006/relationships" id="256" r:id="R8439e790e0f44805"/>
-    <p:sldId xmlns:r="http://schemas.openxmlformats.org/officeDocument/2006/relationships" id="257" r:id="R19ab7354bbe64889"/>
-    <p:sldId xmlns:r="http://schemas.openxmlformats.org/officeDocument/2006/relationships" id="258" r:id="Rfbb51ea2ddb04df6"/>
-    <p:sldId xmlns:r="http://schemas.openxmlformats.org/officeDocument/2006/relationships" id="259" r:id="R57c16d05361f49c9"/>
-    <p:sldId xmlns:r="http://schemas.openxmlformats.org/officeDocument/2006/relationships" id="260" r:id="Rfaf594118d3245e5"/>
-    <p:sldId xmlns:r="http://schemas.openxmlformats.org/officeDocument/2006/relationships" id="261" r:id="Ra2c9bf41100043da"/>
-    <p:sldId xmlns:r="http://schemas.openxmlformats.org/officeDocument/2006/relationships" id="262" r:id="R85d44fff14d14db7"/>
-    <p:sldId xmlns:r="http://schemas.openxmlformats.org/officeDocument/2006/relationships" id="263" r:id="Rf159e2568e514292"/>
-    <p:sldId xmlns:r="http://schemas.openxmlformats.org/officeDocument/2006/relationships" id="264" r:id="Rb1c7e41dbd86472a"/>
-    <p:sldId xmlns:r="http://schemas.openxmlformats.org/officeDocument/2006/relationships" id="265" r:id="Rdc20eced360d4486"/>
+    <p:sldId xmlns:r="http://schemas.openxmlformats.org/officeDocument/2006/relationships" id="256" r:id="Rb8de7bedaa4749ea"/>
+    <p:sldId xmlns:r="http://schemas.openxmlformats.org/officeDocument/2006/relationships" id="257" r:id="Rc633089a9f4c4b40"/>
+    <p:sldId xmlns:r="http://schemas.openxmlformats.org/officeDocument/2006/relationships" id="258" r:id="Rcff43ffdcd874b39"/>
+    <p:sldId xmlns:r="http://schemas.openxmlformats.org/officeDocument/2006/relationships" id="259" r:id="R3e79cc851793482c"/>
+    <p:sldId xmlns:r="http://schemas.openxmlformats.org/officeDocument/2006/relationships" id="260" r:id="Re15764585dfe4869"/>
+    <p:sldId xmlns:r="http://schemas.openxmlformats.org/officeDocument/2006/relationships" id="261" r:id="R6b698f87e3e2481d"/>
+    <p:sldId xmlns:r="http://schemas.openxmlformats.org/officeDocument/2006/relationships" id="262" r:id="R62a88c0c79ce4ad0"/>
+    <p:sldId xmlns:r="http://schemas.openxmlformats.org/officeDocument/2006/relationships" id="263" r:id="R14579cb83f244e8f"/>
+    <p:sldId xmlns:r="http://schemas.openxmlformats.org/officeDocument/2006/relationships" id="264" r:id="Raacd79f101d04e06"/>
+    <p:sldId xmlns:r="http://schemas.openxmlformats.org/officeDocument/2006/relationships" id="265" r:id="Rfe859b4c91e04a83"/>
   </p:sldIdLst>
   <p:sldSz cx="12192000" cy="6858000"/>
   <p:notesSz cx="6858000" cy="9144000"/>
@@ -836,7 +836,7 @@
           <a:lstStyle xmlns:a="http://schemas.openxmlformats.org/drawingml/2006/main"/>
           <a:p xmlns:a="http://schemas.openxmlformats.org/drawingml/2006/main">
             <a:r>
-              <a:t>Stress that StopAsyncIteration is not a success signal. The strict grammar requires explicit provider completion after reconciliation; malformed or premature streams select a fixed safe failure without echoing payload content.</a:t>
+              <a:t>Stress that StopAsyncIteration is not a success signal. Empty completed text is a legal non-terminal candidate only when a following tool request selects tool_unavailable; usage and ProviderCompleted still require accepted non-empty deltas. Other malformed or premature streams select a fixed safe failure without echoing payload content.</a:t>
             </a:r>
           </a:p>
           <a:p xmlns:a="http://schemas.openxmlformats.org/drawingml/2006/main">
@@ -861,7 +861,7 @@
           </a:p>
           <a:p xmlns:a="http://schemas.openxmlformats.org/drawingml/2006/main">
             <a:r>
-              <a:t>- tests/test_provider_session.py (invalid ordering and early EOF cases)</a:t>
+              <a:t>- tests/test_provider_session.py (tool-only prefix, invalid ordering, and early EOF cases)</a:t>
             </a:r>
           </a:p>
           <a:p xmlns:a="http://schemas.openxmlformats.org/drawingml/2006/main">
@@ -1131,7 +1131,7 @@
           <a:lstStyle xmlns:a="http://schemas.openxmlformats.org/drawingml/2006/main"/>
           <a:p xmlns:a="http://schemas.openxmlformats.org/drawingml/2006/main">
             <a:r>
-              <a:t>The lock protects a multi-step decision, not merely a collection. Shielding only the wire write would allow cancellation after bytes commit but before reducer or observer acceptance. The whole admitted transaction must settle.</a:t>
+              <a:t>The decision lock serializes the wire write, reducer update, and observer attempt so cancellation cannot interleave with an admitted observation. It is not a database transaction: if a later observer raises, earlier committed effects are not rolled back.</a:t>
             </a:r>
           </a:p>
           <a:p xmlns:a="http://schemas.openxmlformats.org/drawingml/2006/main">
@@ -1147,6 +1147,11 @@
           <a:p xmlns:a="http://schemas.openxmlformats.org/drawingml/2006/main">
             <a:r>
               <a:t>- src/code_assist_harness/provider_session.py (decision lock and shielded publication)</a:t>
+            </a:r>
+          </a:p>
+          <a:p xmlns:a="http://schemas.openxmlformats.org/drawingml/2006/main">
+            <a:r>
+              <a:t>- docs/glossary.md (provider-session transaction and rollback boundary)</a:t>
             </a:r>
           </a:p>
           <a:p xmlns:a="http://schemas.openxmlformats.org/drawingml/2006/main">
@@ -1226,7 +1231,7 @@
           <a:lstStyle xmlns:a="http://schemas.openxmlformats.org/drawingml/2006/main"/>
           <a:p xmlns:a="http://schemas.openxmlformats.org/drawingml/2006/main">
             <a:r>
-              <a:t>Explain outcome selection and terminal publication as separate phases. Cleanup failure is diagnostic evidence beside the outcome, never authority to replace it. Repeated cancellation is shielded until owned work settles.</a:t>
+              <a:t>Explain outcome selection and terminal publication as separate phases. After the provider cleanup barrier returns, ProviderSession cancels and joins any still-pending local read. A successful barrier remains authoritative, while barrier or reaping exceptions add one bounded diagnostic without replacing the outcome. The local join requires a cancellation-responsive iterator; suppressing task cancellation needs stronger process isolation.</a:t>
             </a:r>
           </a:p>
           <a:p xmlns:a="http://schemas.openxmlformats.org/drawingml/2006/main">
@@ -1241,17 +1246,22 @@
           </a:p>
           <a:p xmlns:a="http://schemas.openxmlformats.org/drawingml/2006/main">
             <a:r>
-              <a:t>- src/code_assist_harness/provider_session.py (selected finalizer and cleanup diagnostic)</a:t>
-            </a:r>
-          </a:p>
-          <a:p xmlns:a="http://schemas.openxmlformats.org/drawingml/2006/main">
-            <a:r>
-              <a:t>- tests/test_provider_session.py (cleanup failures and repeated cancellation)</a:t>
-            </a:r>
-          </a:p>
-          <a:p xmlns:a="http://schemas.openxmlformats.org/drawingml/2006/main">
-            <a:r>
-              <a:t>- user-stories/cah-021-complete-one-model-turn.md (locked diagnostic payload)</a:t>
+              <a:t>- src/code_assist_harness/provider_session.py (selected finalizer and pending-read reaping)</a:t>
+            </a:r>
+          </a:p>
+          <a:p xmlns:a="http://schemas.openxmlformats.org/drawingml/2006/main">
+            <a:r>
+              <a:t>- tests/test_provider_session.py (early cleanup return and cleanup failures)</a:t>
+            </a:r>
+          </a:p>
+          <a:p xmlns:a="http://schemas.openxmlformats.org/drawingml/2006/main">
+            <a:r>
+              <a:t>- tests/test_runtime.py (EOF and shutdown pending-read regression)</a:t>
+            </a:r>
+          </a:p>
+          <a:p xmlns:a="http://schemas.openxmlformats.org/drawingml/2006/main">
+            <a:r>
+              <a:t>- user-stories/cah-021-complete-one-model-turn.md (cleanup contract and containment limit)</a:t>
             </a:r>
           </a:p>
           <a:p xmlns:a="http://schemas.openxmlformats.org/drawingml/2006/main">
@@ -1424,7 +1434,7 @@
   </p:cSld>
   <p:clrMap bg1="lt1" tx1="dk1" bg2="lt2" tx2="dk2" accent1="accent1" accent2="accent2" accent3="accent3" accent4="accent4" accent5="accent5" accent6="accent6" hlink="hlink" folHlink="folHlink"/>
   <p:sldLayoutIdLst>
-    <p:sldLayoutId xmlns:r="http://schemas.openxmlformats.org/officeDocument/2006/relationships" id="2147483649" r:id="R474703088ef54f76"/>
+    <p:sldLayoutId xmlns:r="http://schemas.openxmlformats.org/officeDocument/2006/relationships" id="2147483649" r:id="R3da1ae08398943c4"/>
   </p:sldLayoutIdLst>
   <p:txStyles>
     <p:titleStyle>
@@ -2036,6 +2046,7 @@
           <a:lstStyle xmlns:a="http://schemas.openxmlformats.org/drawingml/2006/main"/>
           <a:p xmlns:a="http://schemas.openxmlformats.org/drawingml/2006/main">
             <a:pPr algn="l">
+              <a:buNone/>
               <a:defRPr sz="1200" b="1">
                 <a:solidFill>
                   <a:srgbClr val="3D8DFF"/>
@@ -2094,6 +2105,7 @@
           <a:lstStyle xmlns:a="http://schemas.openxmlformats.org/drawingml/2006/main"/>
           <a:p xmlns:a="http://schemas.openxmlformats.org/drawingml/2006/main">
             <a:pPr algn="l">
+              <a:buNone/>
               <a:defRPr sz="6000" b="1">
                 <a:solidFill>
                   <a:srgbClr val="000000"/>
@@ -2117,6 +2129,7 @@
           </a:p>
           <a:p xmlns:a="http://schemas.openxmlformats.org/drawingml/2006/main">
             <a:pPr algn="l">
+              <a:buNone/>
               <a:defRPr sz="6000" b="1">
                 <a:solidFill>
                   <a:srgbClr val="000000"/>
@@ -2175,6 +2188,7 @@
           <a:lstStyle xmlns:a="http://schemas.openxmlformats.org/drawingml/2006/main"/>
           <a:p xmlns:a="http://schemas.openxmlformats.org/drawingml/2006/main">
             <a:pPr algn="l">
+              <a:buNone/>
               <a:defRPr sz="2100" b="0">
                 <a:solidFill>
                   <a:srgbClr val="555B66"/>
@@ -2264,6 +2278,7 @@
           <a:lstStyle xmlns:a="http://schemas.openxmlformats.org/drawingml/2006/main"/>
           <a:p xmlns:a="http://schemas.openxmlformats.org/drawingml/2006/main">
             <a:pPr algn="ctr">
+              <a:buNone/>
               <a:defRPr sz="9150" b="1">
                 <a:solidFill>
                   <a:srgbClr val="3D8DFF"/>
@@ -2322,6 +2337,7 @@
           <a:lstStyle xmlns:a="http://schemas.openxmlformats.org/drawingml/2006/main"/>
           <a:p xmlns:a="http://schemas.openxmlformats.org/drawingml/2006/main">
             <a:pPr algn="ctr">
+              <a:buNone/>
               <a:defRPr sz="1500" b="0">
                 <a:solidFill>
                   <a:srgbClr val="555B66"/>
@@ -2380,6 +2396,7 @@
           <a:lstStyle xmlns:a="http://schemas.openxmlformats.org/drawingml/2006/main"/>
           <a:p xmlns:a="http://schemas.openxmlformats.org/drawingml/2006/main">
             <a:pPr algn="l">
+              <a:buNone/>
               <a:defRPr sz="1050" b="1">
                 <a:solidFill>
                   <a:srgbClr val="000000"/>
@@ -2467,6 +2484,7 @@
           <a:lstStyle xmlns:a="http://schemas.openxmlformats.org/drawingml/2006/main"/>
           <a:p xmlns:a="http://schemas.openxmlformats.org/drawingml/2006/main">
             <a:pPr algn="l">
+              <a:buNone/>
               <a:defRPr sz="1125" b="1">
                 <a:solidFill>
                   <a:srgbClr val="3D8DFF"/>
@@ -2525,6 +2543,7 @@
           <a:lstStyle xmlns:a="http://schemas.openxmlformats.org/drawingml/2006/main"/>
           <a:p xmlns:a="http://schemas.openxmlformats.org/drawingml/2006/main">
             <a:pPr algn="l">
+              <a:buNone/>
               <a:defRPr sz="4350" b="1">
                 <a:solidFill>
                   <a:srgbClr val="000000"/>
@@ -2548,6 +2567,7 @@
           </a:p>
           <a:p xmlns:a="http://schemas.openxmlformats.org/drawingml/2006/main">
             <a:pPr algn="l">
+              <a:buNone/>
               <a:defRPr sz="4350" b="1">
                 <a:solidFill>
                   <a:srgbClr val="000000"/>
@@ -2637,6 +2657,7 @@
           <a:lstStyle xmlns:a="http://schemas.openxmlformats.org/drawingml/2006/main"/>
           <a:p xmlns:a="http://schemas.openxmlformats.org/drawingml/2006/main">
             <a:pPr algn="ctr">
+              <a:buNone/>
               <a:defRPr sz="1125" b="1">
                 <a:solidFill>
                   <a:srgbClr val="FFFFFF"/>
@@ -2695,6 +2716,7 @@
           <a:lstStyle xmlns:a="http://schemas.openxmlformats.org/drawingml/2006/main"/>
           <a:p xmlns:a="http://schemas.openxmlformats.org/drawingml/2006/main">
             <a:pPr algn="l">
+              <a:buNone/>
               <a:defRPr sz="1500" b="1">
                 <a:solidFill>
                   <a:srgbClr val="000000"/>
@@ -2753,6 +2775,7 @@
           <a:lstStyle xmlns:a="http://schemas.openxmlformats.org/drawingml/2006/main"/>
           <a:p xmlns:a="http://schemas.openxmlformats.org/drawingml/2006/main">
             <a:pPr algn="l">
+              <a:buNone/>
               <a:defRPr sz="1275" b="0">
                 <a:solidFill>
                   <a:srgbClr val="555B66"/>
@@ -2842,6 +2865,7 @@
           <a:lstStyle xmlns:a="http://schemas.openxmlformats.org/drawingml/2006/main"/>
           <a:p xmlns:a="http://schemas.openxmlformats.org/drawingml/2006/main">
             <a:pPr algn="ctr">
+              <a:buNone/>
               <a:defRPr sz="1125" b="1">
                 <a:solidFill>
                   <a:srgbClr val="FFFFFF"/>
@@ -2900,6 +2924,7 @@
           <a:lstStyle xmlns:a="http://schemas.openxmlformats.org/drawingml/2006/main"/>
           <a:p xmlns:a="http://schemas.openxmlformats.org/drawingml/2006/main">
             <a:pPr algn="l">
+              <a:buNone/>
               <a:defRPr sz="1500" b="1">
                 <a:solidFill>
                   <a:srgbClr val="000000"/>
@@ -2958,6 +2983,7 @@
           <a:lstStyle xmlns:a="http://schemas.openxmlformats.org/drawingml/2006/main"/>
           <a:p xmlns:a="http://schemas.openxmlformats.org/drawingml/2006/main">
             <a:pPr algn="l">
+              <a:buNone/>
               <a:defRPr sz="1275" b="0">
                 <a:solidFill>
                   <a:srgbClr val="555B66"/>
@@ -3047,6 +3073,7 @@
           <a:lstStyle xmlns:a="http://schemas.openxmlformats.org/drawingml/2006/main"/>
           <a:p xmlns:a="http://schemas.openxmlformats.org/drawingml/2006/main">
             <a:pPr algn="ctr">
+              <a:buNone/>
               <a:defRPr sz="1125" b="1">
                 <a:solidFill>
                   <a:srgbClr val="FFFFFF"/>
@@ -3105,6 +3132,7 @@
           <a:lstStyle xmlns:a="http://schemas.openxmlformats.org/drawingml/2006/main"/>
           <a:p xmlns:a="http://schemas.openxmlformats.org/drawingml/2006/main">
             <a:pPr algn="l">
+              <a:buNone/>
               <a:defRPr sz="1500" b="1">
                 <a:solidFill>
                   <a:srgbClr val="000000"/>
@@ -3163,6 +3191,7 @@
           <a:lstStyle xmlns:a="http://schemas.openxmlformats.org/drawingml/2006/main"/>
           <a:p xmlns:a="http://schemas.openxmlformats.org/drawingml/2006/main">
             <a:pPr algn="l">
+              <a:buNone/>
               <a:defRPr sz="1275" b="0">
                 <a:solidFill>
                   <a:srgbClr val="555B66"/>
@@ -3252,6 +3281,7 @@
           <a:lstStyle xmlns:a="http://schemas.openxmlformats.org/drawingml/2006/main"/>
           <a:p xmlns:a="http://schemas.openxmlformats.org/drawingml/2006/main">
             <a:pPr algn="ctr">
+              <a:buNone/>
               <a:defRPr sz="1125" b="1">
                 <a:solidFill>
                   <a:srgbClr val="FFFFFF"/>
@@ -3310,6 +3340,7 @@
           <a:lstStyle xmlns:a="http://schemas.openxmlformats.org/drawingml/2006/main"/>
           <a:p xmlns:a="http://schemas.openxmlformats.org/drawingml/2006/main">
             <a:pPr algn="l">
+              <a:buNone/>
               <a:defRPr sz="1500" b="1">
                 <a:solidFill>
                   <a:srgbClr val="000000"/>
@@ -3368,6 +3399,7 @@
           <a:lstStyle xmlns:a="http://schemas.openxmlformats.org/drawingml/2006/main"/>
           <a:p xmlns:a="http://schemas.openxmlformats.org/drawingml/2006/main">
             <a:pPr algn="l">
+              <a:buNone/>
               <a:defRPr sz="1275" b="0">
                 <a:solidFill>
                   <a:srgbClr val="555B66"/>
@@ -3457,6 +3489,7 @@
           <a:lstStyle xmlns:a="http://schemas.openxmlformats.org/drawingml/2006/main"/>
           <a:p xmlns:a="http://schemas.openxmlformats.org/drawingml/2006/main">
             <a:pPr algn="l">
+              <a:buNone/>
               <a:defRPr sz="1800" b="1">
                 <a:solidFill>
                   <a:srgbClr val="000000"/>
@@ -3515,6 +3548,7 @@
           <a:lstStyle xmlns:a="http://schemas.openxmlformats.org/drawingml/2006/main"/>
           <a:p xmlns:a="http://schemas.openxmlformats.org/drawingml/2006/main">
             <a:pPr algn="r">
+              <a:buNone/>
               <a:defRPr sz="1350" b="1">
                 <a:solidFill>
                   <a:srgbClr val="3D8DFF"/>
@@ -3602,6 +3636,7 @@
           <a:lstStyle xmlns:a="http://schemas.openxmlformats.org/drawingml/2006/main"/>
           <a:p xmlns:a="http://schemas.openxmlformats.org/drawingml/2006/main">
             <a:pPr algn="l">
+              <a:buNone/>
               <a:defRPr sz="1050" b="1">
                 <a:solidFill>
                   <a:srgbClr val="3D8DFF"/>
@@ -3660,6 +3695,7 @@
           <a:lstStyle xmlns:a="http://schemas.openxmlformats.org/drawingml/2006/main"/>
           <a:p xmlns:a="http://schemas.openxmlformats.org/drawingml/2006/main">
             <a:pPr algn="l">
+              <a:buNone/>
               <a:defRPr sz="3000" b="1">
                 <a:solidFill>
                   <a:srgbClr val="000000"/>
@@ -3718,6 +3754,7 @@
           <a:lstStyle xmlns:a="http://schemas.openxmlformats.org/drawingml/2006/main"/>
           <a:p xmlns:a="http://schemas.openxmlformats.org/drawingml/2006/main">
             <a:pPr algn="r">
+              <a:buNone/>
               <a:defRPr sz="975" b="0">
                 <a:solidFill>
                   <a:srgbClr val="555B66"/>
@@ -3840,6 +3877,7 @@
           <a:lstStyle xmlns:a="http://schemas.openxmlformats.org/drawingml/2006/main"/>
           <a:p xmlns:a="http://schemas.openxmlformats.org/drawingml/2006/main">
             <a:pPr algn="ctr">
+              <a:buNone/>
               <a:defRPr sz="1275" b="1">
                 <a:solidFill>
                   <a:srgbClr val="FFFFFF"/>
@@ -3898,6 +3936,7 @@
           <a:lstStyle xmlns:a="http://schemas.openxmlformats.org/drawingml/2006/main"/>
           <a:p xmlns:a="http://schemas.openxmlformats.org/drawingml/2006/main">
             <a:pPr algn="l">
+              <a:buNone/>
               <a:defRPr sz="1725" b="1">
                 <a:solidFill>
                   <a:srgbClr val="000000"/>
@@ -3923,7 +3962,7 @@
       </p:sp>
       <p:cxnSp>
         <p:nvCxnSpPr>
-          <p:cNvPr id="31" name=""/>
+          <p:cNvPr id="51" name=""/>
           <p:cNvCxnSpPr/>
           <p:nvPr/>
         </p:nvCxnSpPr>
@@ -3978,6 +4017,7 @@
           <a:lstStyle xmlns:a="http://schemas.openxmlformats.org/drawingml/2006/main"/>
           <a:p xmlns:a="http://schemas.openxmlformats.org/drawingml/2006/main">
             <a:pPr algn="l">
+              <a:buNone/>
               <a:defRPr sz="1500" b="0">
                 <a:solidFill>
                   <a:srgbClr val="555B66"/>
@@ -4100,6 +4140,7 @@
           <a:lstStyle xmlns:a="http://schemas.openxmlformats.org/drawingml/2006/main"/>
           <a:p xmlns:a="http://schemas.openxmlformats.org/drawingml/2006/main">
             <a:pPr algn="ctr">
+              <a:buNone/>
               <a:defRPr sz="1275" b="1">
                 <a:solidFill>
                   <a:srgbClr val="FFFFFF"/>
@@ -4158,6 +4199,7 @@
           <a:lstStyle xmlns:a="http://schemas.openxmlformats.org/drawingml/2006/main"/>
           <a:p xmlns:a="http://schemas.openxmlformats.org/drawingml/2006/main">
             <a:pPr algn="l">
+              <a:buNone/>
               <a:defRPr sz="1725" b="1">
                 <a:solidFill>
                   <a:srgbClr val="000000"/>
@@ -4183,7 +4225,7 @@
       </p:sp>
       <p:cxnSp>
         <p:nvCxnSpPr>
-          <p:cNvPr id="37" name=""/>
+          <p:cNvPr id="57" name=""/>
           <p:cNvCxnSpPr/>
           <p:nvPr/>
         </p:nvCxnSpPr>
@@ -4238,6 +4280,7 @@
           <a:lstStyle xmlns:a="http://schemas.openxmlformats.org/drawingml/2006/main"/>
           <a:p xmlns:a="http://schemas.openxmlformats.org/drawingml/2006/main">
             <a:pPr algn="l">
+              <a:buNone/>
               <a:defRPr sz="1500" b="0">
                 <a:solidFill>
                   <a:srgbClr val="555B66"/>
@@ -4360,6 +4403,7 @@
           <a:lstStyle xmlns:a="http://schemas.openxmlformats.org/drawingml/2006/main"/>
           <a:p xmlns:a="http://schemas.openxmlformats.org/drawingml/2006/main">
             <a:pPr algn="ctr">
+              <a:buNone/>
               <a:defRPr sz="1275" b="1">
                 <a:solidFill>
                   <a:srgbClr val="FFFFFF"/>
@@ -4418,6 +4462,7 @@
           <a:lstStyle xmlns:a="http://schemas.openxmlformats.org/drawingml/2006/main"/>
           <a:p xmlns:a="http://schemas.openxmlformats.org/drawingml/2006/main">
             <a:pPr algn="l">
+              <a:buNone/>
               <a:defRPr sz="1725" b="1">
                 <a:solidFill>
                   <a:srgbClr val="000000"/>
@@ -4443,7 +4488,7 @@
       </p:sp>
       <p:cxnSp>
         <p:nvCxnSpPr>
-          <p:cNvPr id="43" name=""/>
+          <p:cNvPr id="63" name=""/>
           <p:cNvCxnSpPr/>
           <p:nvPr/>
         </p:nvCxnSpPr>
@@ -4498,6 +4543,7 @@
           <a:lstStyle xmlns:a="http://schemas.openxmlformats.org/drawingml/2006/main"/>
           <a:p xmlns:a="http://schemas.openxmlformats.org/drawingml/2006/main">
             <a:pPr algn="l">
+              <a:buNone/>
               <a:defRPr sz="1500" b="0">
                 <a:solidFill>
                   <a:srgbClr val="555B66"/>
@@ -4587,6 +4633,7 @@
           <a:lstStyle xmlns:a="http://schemas.openxmlformats.org/drawingml/2006/main"/>
           <a:p xmlns:a="http://schemas.openxmlformats.org/drawingml/2006/main">
             <a:pPr algn="ctr">
+              <a:buNone/>
               <a:defRPr sz="1500" b="1">
                 <a:solidFill>
                   <a:srgbClr val="000000"/>
@@ -4674,6 +4721,7 @@
           <a:lstStyle xmlns:a="http://schemas.openxmlformats.org/drawingml/2006/main"/>
           <a:p xmlns:a="http://schemas.openxmlformats.org/drawingml/2006/main">
             <a:pPr algn="l">
+              <a:buNone/>
               <a:defRPr sz="1050" b="1">
                 <a:solidFill>
                   <a:srgbClr val="3D8DFF"/>
@@ -4732,6 +4780,7 @@
           <a:lstStyle xmlns:a="http://schemas.openxmlformats.org/drawingml/2006/main"/>
           <a:p xmlns:a="http://schemas.openxmlformats.org/drawingml/2006/main">
             <a:pPr algn="l">
+              <a:buNone/>
               <a:defRPr sz="3000" b="1">
                 <a:solidFill>
                   <a:srgbClr val="000000"/>
@@ -4790,6 +4839,7 @@
           <a:lstStyle xmlns:a="http://schemas.openxmlformats.org/drawingml/2006/main"/>
           <a:p xmlns:a="http://schemas.openxmlformats.org/drawingml/2006/main">
             <a:pPr algn="r">
+              <a:buNone/>
               <a:defRPr sz="975" b="0">
                 <a:solidFill>
                   <a:srgbClr val="555B66"/>
@@ -4815,7 +4865,7 @@
       </p:sp>
       <p:cxnSp>
         <p:nvCxnSpPr>
-          <p:cNvPr id="38" name=""/>
+          <p:cNvPr id="42" name=""/>
           <p:cNvCxnSpPr/>
           <p:nvPr/>
         </p:nvCxnSpPr>
@@ -4901,6 +4951,7 @@
           <a:lstStyle xmlns:a="http://schemas.openxmlformats.org/drawingml/2006/main"/>
           <a:p xmlns:a="http://schemas.openxmlformats.org/drawingml/2006/main">
             <a:pPr algn="ctr">
+              <a:buNone/>
               <a:defRPr sz="1200" b="1">
                 <a:solidFill>
                   <a:srgbClr val="FFFFFF"/>
@@ -4959,6 +5010,7 @@
           <a:lstStyle xmlns:a="http://schemas.openxmlformats.org/drawingml/2006/main"/>
           <a:p xmlns:a="http://schemas.openxmlformats.org/drawingml/2006/main">
             <a:pPr algn="ctr">
+              <a:buNone/>
               <a:defRPr sz="1275" b="1">
                 <a:solidFill>
                   <a:srgbClr val="000000"/>
@@ -5017,6 +5069,7 @@
           <a:lstStyle xmlns:a="http://schemas.openxmlformats.org/drawingml/2006/main"/>
           <a:p xmlns:a="http://schemas.openxmlformats.org/drawingml/2006/main">
             <a:pPr algn="ctr">
+              <a:buNone/>
               <a:defRPr sz="1350" b="0">
                 <a:solidFill>
                   <a:srgbClr val="555B66"/>
@@ -5106,6 +5159,7 @@
           <a:lstStyle xmlns:a="http://schemas.openxmlformats.org/drawingml/2006/main"/>
           <a:p xmlns:a="http://schemas.openxmlformats.org/drawingml/2006/main">
             <a:pPr algn="ctr">
+              <a:buNone/>
               <a:defRPr sz="1200" b="1">
                 <a:solidFill>
                   <a:srgbClr val="FFFFFF"/>
@@ -5164,6 +5218,7 @@
           <a:lstStyle xmlns:a="http://schemas.openxmlformats.org/drawingml/2006/main"/>
           <a:p xmlns:a="http://schemas.openxmlformats.org/drawingml/2006/main">
             <a:pPr algn="ctr">
+              <a:buNone/>
               <a:defRPr sz="1275" b="1">
                 <a:solidFill>
                   <a:srgbClr val="000000"/>
@@ -5222,6 +5277,7 @@
           <a:lstStyle xmlns:a="http://schemas.openxmlformats.org/drawingml/2006/main"/>
           <a:p xmlns:a="http://schemas.openxmlformats.org/drawingml/2006/main">
             <a:pPr algn="ctr">
+              <a:buNone/>
               <a:defRPr sz="1350" b="0">
                 <a:solidFill>
                   <a:srgbClr val="555B66"/>
@@ -5311,6 +5367,7 @@
           <a:lstStyle xmlns:a="http://schemas.openxmlformats.org/drawingml/2006/main"/>
           <a:p xmlns:a="http://schemas.openxmlformats.org/drawingml/2006/main">
             <a:pPr algn="ctr">
+              <a:buNone/>
               <a:defRPr sz="1200" b="1">
                 <a:solidFill>
                   <a:srgbClr val="FFFFFF"/>
@@ -5369,6 +5426,7 @@
           <a:lstStyle xmlns:a="http://schemas.openxmlformats.org/drawingml/2006/main"/>
           <a:p xmlns:a="http://schemas.openxmlformats.org/drawingml/2006/main">
             <a:pPr algn="ctr">
+              <a:buNone/>
               <a:defRPr sz="1275" b="1">
                 <a:solidFill>
                   <a:srgbClr val="000000"/>
@@ -5427,6 +5485,7 @@
           <a:lstStyle xmlns:a="http://schemas.openxmlformats.org/drawingml/2006/main"/>
           <a:p xmlns:a="http://schemas.openxmlformats.org/drawingml/2006/main">
             <a:pPr algn="ctr">
+              <a:buNone/>
               <a:defRPr sz="1350" b="0">
                 <a:solidFill>
                   <a:srgbClr val="555B66"/>
@@ -5516,6 +5575,7 @@
           <a:lstStyle xmlns:a="http://schemas.openxmlformats.org/drawingml/2006/main"/>
           <a:p xmlns:a="http://schemas.openxmlformats.org/drawingml/2006/main">
             <a:pPr algn="ctr">
+              <a:buNone/>
               <a:defRPr sz="1200" b="1">
                 <a:solidFill>
                   <a:srgbClr val="FFFFFF"/>
@@ -5574,6 +5634,7 @@
           <a:lstStyle xmlns:a="http://schemas.openxmlformats.org/drawingml/2006/main"/>
           <a:p xmlns:a="http://schemas.openxmlformats.org/drawingml/2006/main">
             <a:pPr algn="ctr">
+              <a:buNone/>
               <a:defRPr sz="1275" b="1">
                 <a:solidFill>
                   <a:srgbClr val="000000"/>
@@ -5632,6 +5693,7 @@
           <a:lstStyle xmlns:a="http://schemas.openxmlformats.org/drawingml/2006/main"/>
           <a:p xmlns:a="http://schemas.openxmlformats.org/drawingml/2006/main">
             <a:pPr algn="ctr">
+              <a:buNone/>
               <a:defRPr sz="1350" b="0">
                 <a:solidFill>
                   <a:srgbClr val="555B66"/>
@@ -5721,6 +5783,7 @@
           <a:lstStyle xmlns:a="http://schemas.openxmlformats.org/drawingml/2006/main"/>
           <a:p xmlns:a="http://schemas.openxmlformats.org/drawingml/2006/main">
             <a:pPr algn="ctr">
+              <a:buNone/>
               <a:defRPr sz="1200" b="1">
                 <a:solidFill>
                   <a:srgbClr val="FFFFFF"/>
@@ -5779,6 +5842,7 @@
           <a:lstStyle xmlns:a="http://schemas.openxmlformats.org/drawingml/2006/main"/>
           <a:p xmlns:a="http://schemas.openxmlformats.org/drawingml/2006/main">
             <a:pPr algn="ctr">
+              <a:buNone/>
               <a:defRPr sz="1275" b="1">
                 <a:solidFill>
                   <a:srgbClr val="000000"/>
@@ -5837,6 +5901,7 @@
           <a:lstStyle xmlns:a="http://schemas.openxmlformats.org/drawingml/2006/main"/>
           <a:p xmlns:a="http://schemas.openxmlformats.org/drawingml/2006/main">
             <a:pPr algn="ctr">
+              <a:buNone/>
               <a:defRPr sz="1350" b="0">
                 <a:solidFill>
                   <a:srgbClr val="555B66"/>
@@ -5926,6 +5991,7 @@
           <a:lstStyle xmlns:a="http://schemas.openxmlformats.org/drawingml/2006/main"/>
           <a:p xmlns:a="http://schemas.openxmlformats.org/drawingml/2006/main">
             <a:pPr algn="ctr">
+              <a:buNone/>
               <a:defRPr sz="1200" b="1">
                 <a:solidFill>
                   <a:srgbClr val="FFFFFF"/>
@@ -5984,6 +6050,7 @@
           <a:lstStyle xmlns:a="http://schemas.openxmlformats.org/drawingml/2006/main"/>
           <a:p xmlns:a="http://schemas.openxmlformats.org/drawingml/2006/main">
             <a:pPr algn="ctr">
+              <a:buNone/>
               <a:defRPr sz="1275" b="1">
                 <a:solidFill>
                   <a:srgbClr val="000000"/>
@@ -6042,6 +6109,7 @@
           <a:lstStyle xmlns:a="http://schemas.openxmlformats.org/drawingml/2006/main"/>
           <a:p xmlns:a="http://schemas.openxmlformats.org/drawingml/2006/main">
             <a:pPr algn="ctr">
+              <a:buNone/>
               <a:defRPr sz="1350" b="0">
                 <a:solidFill>
                   <a:srgbClr val="555B66"/>
@@ -6131,6 +6199,7 @@
           <a:lstStyle xmlns:a="http://schemas.openxmlformats.org/drawingml/2006/main"/>
           <a:p xmlns:a="http://schemas.openxmlformats.org/drawingml/2006/main">
             <a:pPr algn="ctr">
+              <a:buNone/>
               <a:defRPr sz="1200" b="1">
                 <a:solidFill>
                   <a:srgbClr val="FFFFFF"/>
@@ -6189,6 +6258,7 @@
           <a:lstStyle xmlns:a="http://schemas.openxmlformats.org/drawingml/2006/main"/>
           <a:p xmlns:a="http://schemas.openxmlformats.org/drawingml/2006/main">
             <a:pPr algn="ctr">
+              <a:buNone/>
               <a:defRPr sz="1275" b="1">
                 <a:solidFill>
                   <a:srgbClr val="000000"/>
@@ -6247,6 +6317,7 @@
           <a:lstStyle xmlns:a="http://schemas.openxmlformats.org/drawingml/2006/main"/>
           <a:p xmlns:a="http://schemas.openxmlformats.org/drawingml/2006/main">
             <a:pPr algn="ctr">
+              <a:buNone/>
               <a:defRPr sz="1350" b="0">
                 <a:solidFill>
                   <a:srgbClr val="555B66"/>
@@ -6336,6 +6407,7 @@
           <a:lstStyle xmlns:a="http://schemas.openxmlformats.org/drawingml/2006/main"/>
           <a:p xmlns:a="http://schemas.openxmlformats.org/drawingml/2006/main">
             <a:pPr algn="ctr">
+              <a:buNone/>
               <a:defRPr sz="1725" b="1">
                 <a:solidFill>
                   <a:srgbClr val="000000"/>
@@ -6423,6 +6495,7 @@
           <a:lstStyle xmlns:a="http://schemas.openxmlformats.org/drawingml/2006/main"/>
           <a:p xmlns:a="http://schemas.openxmlformats.org/drawingml/2006/main">
             <a:pPr algn="l">
+              <a:buNone/>
               <a:defRPr sz="1050" b="1">
                 <a:solidFill>
                   <a:srgbClr val="3D8DFF"/>
@@ -6481,6 +6554,7 @@
           <a:lstStyle xmlns:a="http://schemas.openxmlformats.org/drawingml/2006/main"/>
           <a:p xmlns:a="http://schemas.openxmlformats.org/drawingml/2006/main">
             <a:pPr algn="l">
+              <a:buNone/>
               <a:defRPr sz="3000" b="1">
                 <a:solidFill>
                   <a:srgbClr val="000000"/>
@@ -6539,6 +6613,7 @@
           <a:lstStyle xmlns:a="http://schemas.openxmlformats.org/drawingml/2006/main"/>
           <a:p xmlns:a="http://schemas.openxmlformats.org/drawingml/2006/main">
             <a:pPr algn="r">
+              <a:buNone/>
               <a:defRPr sz="975" b="0">
                 <a:solidFill>
                   <a:srgbClr val="555B66"/>
@@ -6597,6 +6672,7 @@
           <a:lstStyle xmlns:a="http://schemas.openxmlformats.org/drawingml/2006/main"/>
           <a:p xmlns:a="http://schemas.openxmlformats.org/drawingml/2006/main">
             <a:pPr algn="l">
+              <a:buNone/>
               <a:defRPr sz="1125" b="1">
                 <a:solidFill>
                   <a:srgbClr val="3D8DFF"/>
@@ -6686,6 +6762,7 @@
           <a:lstStyle xmlns:a="http://schemas.openxmlformats.org/drawingml/2006/main"/>
           <a:p xmlns:a="http://schemas.openxmlformats.org/drawingml/2006/main">
             <a:pPr algn="l">
+              <a:buNone/>
               <a:defRPr sz="1650" b="1">
                 <a:solidFill>
                   <a:srgbClr val="000000"/>
@@ -6711,7 +6788,7 @@
       </p:sp>
       <p:cxnSp>
         <p:nvCxnSpPr>
-          <p:cNvPr id="42" name=""/>
+          <p:cNvPr id="57" name=""/>
           <p:cNvCxnSpPr/>
           <p:nvPr/>
         </p:nvCxnSpPr>
@@ -6828,6 +6905,7 @@
           <a:lstStyle xmlns:a="http://schemas.openxmlformats.org/drawingml/2006/main"/>
           <a:p xmlns:a="http://schemas.openxmlformats.org/drawingml/2006/main">
             <a:pPr algn="l">
+              <a:buNone/>
               <a:defRPr sz="1650" b="1">
                 <a:solidFill>
                   <a:srgbClr val="000000"/>
@@ -6853,7 +6931,7 @@
       </p:sp>
       <p:cxnSp>
         <p:nvCxnSpPr>
-          <p:cNvPr id="46" name=""/>
+          <p:cNvPr id="61" name=""/>
           <p:cNvCxnSpPr/>
           <p:nvPr/>
         </p:nvCxnSpPr>
@@ -6970,6 +7048,7 @@
           <a:lstStyle xmlns:a="http://schemas.openxmlformats.org/drawingml/2006/main"/>
           <a:p xmlns:a="http://schemas.openxmlformats.org/drawingml/2006/main">
             <a:pPr algn="l">
+              <a:buNone/>
               <a:defRPr sz="1650" b="1">
                 <a:solidFill>
                   <a:srgbClr val="000000"/>
@@ -6995,7 +7074,7 @@
       </p:sp>
       <p:cxnSp>
         <p:nvCxnSpPr>
-          <p:cNvPr id="50" name=""/>
+          <p:cNvPr id="65" name=""/>
           <p:cNvCxnSpPr/>
           <p:nvPr/>
         </p:nvCxnSpPr>
@@ -7112,6 +7191,7 @@
           <a:lstStyle xmlns:a="http://schemas.openxmlformats.org/drawingml/2006/main"/>
           <a:p xmlns:a="http://schemas.openxmlformats.org/drawingml/2006/main">
             <a:pPr algn="l">
+              <a:buNone/>
               <a:defRPr sz="1650" b="1">
                 <a:solidFill>
                   <a:srgbClr val="FFFFFF"/>
@@ -7170,6 +7250,7 @@
           <a:lstStyle xmlns:a="http://schemas.openxmlformats.org/drawingml/2006/main"/>
           <a:p xmlns:a="http://schemas.openxmlformats.org/drawingml/2006/main">
             <a:pPr algn="l">
+              <a:buNone/>
               <a:defRPr sz="1125" b="1">
                 <a:solidFill>
                   <a:srgbClr val="000000"/>
@@ -7188,7 +7269,7 @@
                 <a:ea typeface="Helvetica Neue"/>
                 <a:cs typeface="Helvetica Neue"/>
               </a:rPr>
-              <a:t>INVALID RESPONSE</a:t>
+              <a:t>SPECIAL / INVALID PATHS</a:t>
             </a:r>
           </a:p>
         </p:txBody>
@@ -7259,6 +7340,7 @@
           <a:lstStyle xmlns:a="http://schemas.openxmlformats.org/drawingml/2006/main"/>
           <a:p xmlns:a="http://schemas.openxmlformats.org/drawingml/2006/main">
             <a:pPr algn="ctr">
+              <a:buNone/>
               <a:defRPr sz="1500" b="1">
                 <a:solidFill>
                   <a:srgbClr val="FFFFFF"/>
@@ -7277,7 +7359,7 @@
                 <a:ea typeface="Helvetica Neue"/>
                 <a:cs typeface="Helvetica Neue"/>
               </a:rPr>
-              <a:t>×</a:t>
+              <a:t>→</a:t>
             </a:r>
           </a:p>
         </p:txBody>
@@ -7317,6 +7399,7 @@
           <a:lstStyle xmlns:a="http://schemas.openxmlformats.org/drawingml/2006/main"/>
           <a:p xmlns:a="http://schemas.openxmlformats.org/drawingml/2006/main">
             <a:pPr algn="l">
+              <a:buNone/>
               <a:defRPr sz="1425" b="1">
                 <a:solidFill>
                   <a:srgbClr val="000000"/>
@@ -7335,7 +7418,7 @@
                 <a:ea typeface="Helvetica Neue"/>
                 <a:cs typeface="Helvetica Neue"/>
               </a:rPr>
-              <a:t>EMPTY OR MISSING Δ</a:t>
+              <a:t>EMPTY TEXT CANDIDATE</a:t>
             </a:r>
           </a:p>
         </p:txBody>
@@ -7375,6 +7458,7 @@
           <a:lstStyle xmlns:a="http://schemas.openxmlformats.org/drawingml/2006/main"/>
           <a:p xmlns:a="http://schemas.openxmlformats.org/drawingml/2006/main">
             <a:pPr algn="l">
+              <a:buNone/>
               <a:defRPr sz="1275" b="0">
                 <a:solidFill>
                   <a:srgbClr val="555B66"/>
@@ -7393,7 +7477,7 @@
                 <a:ea typeface="Helvetica Neue"/>
                 <a:cs typeface="Helvetica Neue"/>
               </a:rPr>
-              <a:t>No visible assistant output</a:t>
+              <a:t>Tool request → tool_unavailable; success stays blocked</a:t>
             </a:r>
           </a:p>
         </p:txBody>
@@ -7464,6 +7548,7 @@
           <a:lstStyle xmlns:a="http://schemas.openxmlformats.org/drawingml/2006/main"/>
           <a:p xmlns:a="http://schemas.openxmlformats.org/drawingml/2006/main">
             <a:pPr algn="ctr">
+              <a:buNone/>
               <a:defRPr sz="1500" b="1">
                 <a:solidFill>
                   <a:srgbClr val="FFFFFF"/>
@@ -7522,6 +7607,7 @@
           <a:lstStyle xmlns:a="http://schemas.openxmlformats.org/drawingml/2006/main"/>
           <a:p xmlns:a="http://schemas.openxmlformats.org/drawingml/2006/main">
             <a:pPr algn="l">
+              <a:buNone/>
               <a:defRPr sz="1425" b="1">
                 <a:solidFill>
                   <a:srgbClr val="000000"/>
@@ -7580,6 +7666,7 @@
           <a:lstStyle xmlns:a="http://schemas.openxmlformats.org/drawingml/2006/main"/>
           <a:p xmlns:a="http://schemas.openxmlformats.org/drawingml/2006/main">
             <a:pPr algn="l">
+              <a:buNone/>
               <a:defRPr sz="1275" b="0">
                 <a:solidFill>
                   <a:srgbClr val="555B66"/>
@@ -7669,6 +7756,7 @@
           <a:lstStyle xmlns:a="http://schemas.openxmlformats.org/drawingml/2006/main"/>
           <a:p xmlns:a="http://schemas.openxmlformats.org/drawingml/2006/main">
             <a:pPr algn="ctr">
+              <a:buNone/>
               <a:defRPr sz="1500" b="1">
                 <a:solidFill>
                   <a:srgbClr val="FFFFFF"/>
@@ -7727,6 +7815,7 @@
           <a:lstStyle xmlns:a="http://schemas.openxmlformats.org/drawingml/2006/main"/>
           <a:p xmlns:a="http://schemas.openxmlformats.org/drawingml/2006/main">
             <a:pPr algn="l">
+              <a:buNone/>
               <a:defRPr sz="1425" b="1">
                 <a:solidFill>
                   <a:srgbClr val="000000"/>
@@ -7785,6 +7874,7 @@
           <a:lstStyle xmlns:a="http://schemas.openxmlformats.org/drawingml/2006/main"/>
           <a:p xmlns:a="http://schemas.openxmlformats.org/drawingml/2006/main">
             <a:pPr algn="l">
+              <a:buNone/>
               <a:defRPr sz="1275" b="0">
                 <a:solidFill>
                   <a:srgbClr val="555B66"/>
@@ -7874,6 +7964,7 @@
           <a:lstStyle xmlns:a="http://schemas.openxmlformats.org/drawingml/2006/main"/>
           <a:p xmlns:a="http://schemas.openxmlformats.org/drawingml/2006/main">
             <a:pPr algn="ctr">
+              <a:buNone/>
               <a:defRPr sz="1500" b="1">
                 <a:solidFill>
                   <a:srgbClr val="FFFFFF"/>
@@ -7932,6 +8023,7 @@
           <a:lstStyle xmlns:a="http://schemas.openxmlformats.org/drawingml/2006/main"/>
           <a:p xmlns:a="http://schemas.openxmlformats.org/drawingml/2006/main">
             <a:pPr algn="l">
+              <a:buNone/>
               <a:defRPr sz="1425" b="1">
                 <a:solidFill>
                   <a:srgbClr val="000000"/>
@@ -7990,6 +8082,7 @@
           <a:lstStyle xmlns:a="http://schemas.openxmlformats.org/drawingml/2006/main"/>
           <a:p xmlns:a="http://schemas.openxmlformats.org/drawingml/2006/main">
             <a:pPr algn="l">
+              <a:buNone/>
               <a:defRPr sz="1275" b="0">
                 <a:solidFill>
                   <a:srgbClr val="555B66"/>
@@ -8077,6 +8170,7 @@
           <a:lstStyle xmlns:a="http://schemas.openxmlformats.org/drawingml/2006/main"/>
           <a:p xmlns:a="http://schemas.openxmlformats.org/drawingml/2006/main">
             <a:pPr algn="l">
+              <a:buNone/>
               <a:defRPr sz="1050" b="1">
                 <a:solidFill>
                   <a:srgbClr val="3D8DFF"/>
@@ -8135,6 +8229,7 @@
           <a:lstStyle xmlns:a="http://schemas.openxmlformats.org/drawingml/2006/main"/>
           <a:p xmlns:a="http://schemas.openxmlformats.org/drawingml/2006/main">
             <a:pPr algn="l">
+              <a:buNone/>
               <a:defRPr sz="3000" b="1">
                 <a:solidFill>
                   <a:srgbClr val="000000"/>
@@ -8193,6 +8288,7 @@
           <a:lstStyle xmlns:a="http://schemas.openxmlformats.org/drawingml/2006/main"/>
           <a:p xmlns:a="http://schemas.openxmlformats.org/drawingml/2006/main">
             <a:pPr algn="r">
+              <a:buNone/>
               <a:defRPr sz="975" b="0">
                 <a:solidFill>
                   <a:srgbClr val="555B66"/>
@@ -8251,6 +8347,7 @@
           <a:lstStyle xmlns:a="http://schemas.openxmlformats.org/drawingml/2006/main"/>
           <a:p xmlns:a="http://schemas.openxmlformats.org/drawingml/2006/main">
             <a:pPr algn="l">
+              <a:buNone/>
               <a:defRPr sz="1575" b="0">
                 <a:solidFill>
                   <a:srgbClr val="555B66"/>
@@ -8309,6 +8406,7 @@
           <a:lstStyle xmlns:a="http://schemas.openxmlformats.org/drawingml/2006/main"/>
           <a:p xmlns:a="http://schemas.openxmlformats.org/drawingml/2006/main">
             <a:pPr algn="l">
+              <a:buNone/>
               <a:defRPr sz="1350" b="1">
                 <a:solidFill>
                   <a:srgbClr val="000000"/>
@@ -8334,7 +8432,7 @@
       </p:sp>
       <p:cxnSp>
         <p:nvCxnSpPr>
-          <p:cNvPr id="36" name=""/>
+          <p:cNvPr id="54" name=""/>
           <p:cNvCxnSpPr/>
           <p:nvPr/>
         </p:nvCxnSpPr>
@@ -8420,6 +8518,7 @@
           <a:lstStyle xmlns:a="http://schemas.openxmlformats.org/drawingml/2006/main"/>
           <a:p xmlns:a="http://schemas.openxmlformats.org/drawingml/2006/main">
             <a:pPr algn="ctr">
+              <a:buNone/>
               <a:defRPr sz="1200" b="0">
                 <a:solidFill>
                   <a:srgbClr val="000000"/>
@@ -8509,6 +8608,7 @@
           <a:lstStyle xmlns:a="http://schemas.openxmlformats.org/drawingml/2006/main"/>
           <a:p xmlns:a="http://schemas.openxmlformats.org/drawingml/2006/main">
             <a:pPr algn="ctr">
+              <a:buNone/>
               <a:defRPr sz="1200" b="0">
                 <a:solidFill>
                   <a:srgbClr val="000000"/>
@@ -8598,6 +8698,7 @@
           <a:lstStyle xmlns:a="http://schemas.openxmlformats.org/drawingml/2006/main"/>
           <a:p xmlns:a="http://schemas.openxmlformats.org/drawingml/2006/main">
             <a:pPr algn="ctr">
+              <a:buNone/>
               <a:defRPr sz="1200" b="1">
                 <a:solidFill>
                   <a:srgbClr val="000000"/>
@@ -8687,6 +8788,7 @@
           <a:lstStyle xmlns:a="http://schemas.openxmlformats.org/drawingml/2006/main"/>
           <a:p xmlns:a="http://schemas.openxmlformats.org/drawingml/2006/main">
             <a:pPr algn="ctr">
+              <a:buNone/>
               <a:defRPr sz="1200" b="1">
                 <a:solidFill>
                   <a:srgbClr val="000000"/>
@@ -8776,6 +8878,7 @@
           <a:lstStyle xmlns:a="http://schemas.openxmlformats.org/drawingml/2006/main"/>
           <a:p xmlns:a="http://schemas.openxmlformats.org/drawingml/2006/main">
             <a:pPr algn="ctr">
+              <a:buNone/>
               <a:defRPr sz="1200" b="1">
                 <a:solidFill>
                   <a:srgbClr val="3D8DFF"/>
@@ -8834,6 +8937,7 @@
           <a:lstStyle xmlns:a="http://schemas.openxmlformats.org/drawingml/2006/main"/>
           <a:p xmlns:a="http://schemas.openxmlformats.org/drawingml/2006/main">
             <a:pPr algn="l">
+              <a:buNone/>
               <a:defRPr sz="1350" b="1">
                 <a:solidFill>
                   <a:srgbClr val="000000"/>
@@ -8859,7 +8963,7 @@
       </p:sp>
       <p:cxnSp>
         <p:nvCxnSpPr>
-          <p:cNvPr id="48" name=""/>
+          <p:cNvPr id="66" name=""/>
           <p:cNvCxnSpPr/>
           <p:nvPr/>
         </p:nvCxnSpPr>
@@ -8945,6 +9049,7 @@
           <a:lstStyle xmlns:a="http://schemas.openxmlformats.org/drawingml/2006/main"/>
           <a:p xmlns:a="http://schemas.openxmlformats.org/drawingml/2006/main">
             <a:pPr algn="ctr">
+              <a:buNone/>
               <a:defRPr sz="1200" b="0">
                 <a:solidFill>
                   <a:srgbClr val="000000"/>
@@ -9034,6 +9139,7 @@
           <a:lstStyle xmlns:a="http://schemas.openxmlformats.org/drawingml/2006/main"/>
           <a:p xmlns:a="http://schemas.openxmlformats.org/drawingml/2006/main">
             <a:pPr algn="ctr">
+              <a:buNone/>
               <a:defRPr sz="1200" b="0">
                 <a:solidFill>
                   <a:srgbClr val="000000"/>
@@ -9123,6 +9229,7 @@
           <a:lstStyle xmlns:a="http://schemas.openxmlformats.org/drawingml/2006/main"/>
           <a:p xmlns:a="http://schemas.openxmlformats.org/drawingml/2006/main">
             <a:pPr algn="ctr">
+              <a:buNone/>
               <a:defRPr sz="1200" b="1">
                 <a:solidFill>
                   <a:srgbClr val="000000"/>
@@ -9212,6 +9319,7 @@
           <a:lstStyle xmlns:a="http://schemas.openxmlformats.org/drawingml/2006/main"/>
           <a:p xmlns:a="http://schemas.openxmlformats.org/drawingml/2006/main">
             <a:pPr algn="ctr">
+              <a:buNone/>
               <a:defRPr sz="1200" b="1">
                 <a:solidFill>
                   <a:srgbClr val="000000"/>
@@ -9301,6 +9409,7 @@
           <a:lstStyle xmlns:a="http://schemas.openxmlformats.org/drawingml/2006/main"/>
           <a:p xmlns:a="http://schemas.openxmlformats.org/drawingml/2006/main">
             <a:pPr algn="ctr">
+              <a:buNone/>
               <a:defRPr sz="1200" b="1">
                 <a:solidFill>
                   <a:srgbClr val="000000"/>
@@ -9390,6 +9499,7 @@
           <a:lstStyle xmlns:a="http://schemas.openxmlformats.org/drawingml/2006/main"/>
           <a:p xmlns:a="http://schemas.openxmlformats.org/drawingml/2006/main">
             <a:pPr algn="ctr">
+              <a:buNone/>
               <a:defRPr sz="1350" b="1">
                 <a:solidFill>
                   <a:srgbClr val="000000"/>
@@ -9477,6 +9587,7 @@
           <a:lstStyle xmlns:a="http://schemas.openxmlformats.org/drawingml/2006/main"/>
           <a:p xmlns:a="http://schemas.openxmlformats.org/drawingml/2006/main">
             <a:pPr algn="l">
+              <a:buNone/>
               <a:defRPr sz="1050" b="1">
                 <a:solidFill>
                   <a:srgbClr val="3D8DFF"/>
@@ -9535,6 +9646,7 @@
           <a:lstStyle xmlns:a="http://schemas.openxmlformats.org/drawingml/2006/main"/>
           <a:p xmlns:a="http://schemas.openxmlformats.org/drawingml/2006/main">
             <a:pPr algn="l">
+              <a:buNone/>
               <a:defRPr sz="3000" b="1">
                 <a:solidFill>
                   <a:srgbClr val="000000"/>
@@ -9593,6 +9705,7 @@
           <a:lstStyle xmlns:a="http://schemas.openxmlformats.org/drawingml/2006/main"/>
           <a:p xmlns:a="http://schemas.openxmlformats.org/drawingml/2006/main">
             <a:pPr algn="r">
+              <a:buNone/>
               <a:defRPr sz="975" b="0">
                 <a:solidFill>
                   <a:srgbClr val="555B66"/>
@@ -9651,6 +9764,7 @@
           <a:lstStyle xmlns:a="http://schemas.openxmlformats.org/drawingml/2006/main"/>
           <a:p xmlns:a="http://schemas.openxmlformats.org/drawingml/2006/main">
             <a:pPr algn="l">
+              <a:buNone/>
               <a:defRPr sz="1575" b="0">
                 <a:solidFill>
                   <a:srgbClr val="555B66"/>
@@ -9742,6 +9856,7 @@
           <a:lstStyle xmlns:a="http://schemas.openxmlformats.org/drawingml/2006/main"/>
           <a:p xmlns:a="http://schemas.openxmlformats.org/drawingml/2006/main">
             <a:pPr algn="l">
+              <a:buNone/>
               <a:defRPr sz="5700" b="1">
                 <a:solidFill>
                   <a:srgbClr val="000000"/>
@@ -9800,6 +9915,7 @@
           <a:lstStyle xmlns:a="http://schemas.openxmlformats.org/drawingml/2006/main"/>
           <a:p xmlns:a="http://schemas.openxmlformats.org/drawingml/2006/main">
             <a:pPr algn="l">
+              <a:buNone/>
               <a:defRPr sz="1425" b="1">
                 <a:solidFill>
                   <a:srgbClr val="000000"/>
@@ -9858,6 +9974,7 @@
           <a:lstStyle xmlns:a="http://schemas.openxmlformats.org/drawingml/2006/main"/>
           <a:p xmlns:a="http://schemas.openxmlformats.org/drawingml/2006/main">
             <a:pPr algn="l">
+              <a:buNone/>
               <a:defRPr sz="1350" b="0">
                 <a:solidFill>
                   <a:srgbClr val="555B66"/>
@@ -9949,6 +10066,7 @@
           <a:lstStyle xmlns:a="http://schemas.openxmlformats.org/drawingml/2006/main"/>
           <a:p xmlns:a="http://schemas.openxmlformats.org/drawingml/2006/main">
             <a:pPr algn="l">
+              <a:buNone/>
               <a:defRPr sz="4650" b="1">
                 <a:solidFill>
                   <a:srgbClr val="3D8DFF"/>
@@ -10007,6 +10125,7 @@
           <a:lstStyle xmlns:a="http://schemas.openxmlformats.org/drawingml/2006/main"/>
           <a:p xmlns:a="http://schemas.openxmlformats.org/drawingml/2006/main">
             <a:pPr algn="l">
+              <a:buNone/>
               <a:defRPr sz="1425" b="1">
                 <a:solidFill>
                   <a:srgbClr val="000000"/>
@@ -10065,6 +10184,7 @@
           <a:lstStyle xmlns:a="http://schemas.openxmlformats.org/drawingml/2006/main"/>
           <a:p xmlns:a="http://schemas.openxmlformats.org/drawingml/2006/main">
             <a:pPr algn="l">
+              <a:buNone/>
               <a:defRPr sz="1350" b="0">
                 <a:solidFill>
                   <a:srgbClr val="555B66"/>
@@ -10156,6 +10276,7 @@
           <a:lstStyle xmlns:a="http://schemas.openxmlformats.org/drawingml/2006/main"/>
           <a:p xmlns:a="http://schemas.openxmlformats.org/drawingml/2006/main">
             <a:pPr algn="l">
+              <a:buNone/>
               <a:defRPr sz="5700" b="1">
                 <a:solidFill>
                   <a:srgbClr val="000000"/>
@@ -10214,6 +10335,7 @@
           <a:lstStyle xmlns:a="http://schemas.openxmlformats.org/drawingml/2006/main"/>
           <a:p xmlns:a="http://schemas.openxmlformats.org/drawingml/2006/main">
             <a:pPr algn="l">
+              <a:buNone/>
               <a:defRPr sz="1425" b="1">
                 <a:solidFill>
                   <a:srgbClr val="000000"/>
@@ -10272,6 +10394,7 @@
           <a:lstStyle xmlns:a="http://schemas.openxmlformats.org/drawingml/2006/main"/>
           <a:p xmlns:a="http://schemas.openxmlformats.org/drawingml/2006/main">
             <a:pPr algn="l">
+              <a:buNone/>
               <a:defRPr sz="1350" b="0">
                 <a:solidFill>
                   <a:srgbClr val="555B66"/>
@@ -10330,6 +10453,7 @@
           <a:lstStyle xmlns:a="http://schemas.openxmlformats.org/drawingml/2006/main"/>
           <a:p xmlns:a="http://schemas.openxmlformats.org/drawingml/2006/main">
             <a:pPr algn="l">
+              <a:buNone/>
               <a:defRPr sz="1500" b="1">
                 <a:solidFill>
                   <a:srgbClr val="000000"/>
@@ -10417,6 +10541,7 @@
           <a:lstStyle xmlns:a="http://schemas.openxmlformats.org/drawingml/2006/main"/>
           <a:p xmlns:a="http://schemas.openxmlformats.org/drawingml/2006/main">
             <a:pPr algn="l">
+              <a:buNone/>
               <a:defRPr sz="1050" b="1">
                 <a:solidFill>
                   <a:srgbClr val="3D8DFF"/>
@@ -10475,6 +10600,7 @@
           <a:lstStyle xmlns:a="http://schemas.openxmlformats.org/drawingml/2006/main"/>
           <a:p xmlns:a="http://schemas.openxmlformats.org/drawingml/2006/main">
             <a:pPr algn="l">
+              <a:buNone/>
               <a:defRPr sz="3000" b="1">
                 <a:solidFill>
                   <a:srgbClr val="000000"/>
@@ -10493,7 +10619,7 @@
                 <a:ea typeface="Helvetica Neue"/>
                 <a:cs typeface="Helvetica Neue"/>
               </a:rPr>
-              <a:t>Admission is an all-or-nothing story</a:t>
+              <a:t>Admission is serialized, not reversible</a:t>
             </a:r>
           </a:p>
         </p:txBody>
@@ -10533,6 +10659,7 @@
           <a:lstStyle xmlns:a="http://schemas.openxmlformats.org/drawingml/2006/main"/>
           <a:p xmlns:a="http://schemas.openxmlformats.org/drawingml/2006/main">
             <a:pPr algn="r">
+              <a:buNone/>
               <a:defRPr sz="975" b="0">
                 <a:solidFill>
                   <a:srgbClr val="555B66"/>
@@ -10624,6 +10751,7 @@
           <a:lstStyle xmlns:a="http://schemas.openxmlformats.org/drawingml/2006/main"/>
           <a:p xmlns:a="http://schemas.openxmlformats.org/drawingml/2006/main">
             <a:pPr algn="l">
+              <a:buNone/>
               <a:defRPr sz="1125" b="1">
                 <a:solidFill>
                   <a:srgbClr val="3D8DFF"/>
@@ -10715,6 +10843,7 @@
           <a:lstStyle xmlns:a="http://schemas.openxmlformats.org/drawingml/2006/main"/>
           <a:p xmlns:a="http://schemas.openxmlformats.org/drawingml/2006/main">
             <a:pPr algn="ctr">
+              <a:buNone/>
               <a:defRPr sz="1275" b="1">
                 <a:solidFill>
                   <a:srgbClr val="000000"/>
@@ -10773,6 +10902,7 @@
           <a:lstStyle xmlns:a="http://schemas.openxmlformats.org/drawingml/2006/main"/>
           <a:p xmlns:a="http://schemas.openxmlformats.org/drawingml/2006/main">
             <a:pPr algn="ctr">
+              <a:buNone/>
               <a:defRPr sz="1125" b="0">
                 <a:solidFill>
                   <a:srgbClr val="555B66"/>
@@ -10798,7 +10928,7 @@
       </p:sp>
       <p:cxnSp>
         <p:nvCxnSpPr>
-          <p:cNvPr id="38" name=""/>
+          <p:cNvPr id="57" name=""/>
           <p:cNvCxnSpPr/>
           <p:nvPr/>
         </p:nvCxnSpPr>
@@ -10917,6 +11047,7 @@
           <a:lstStyle xmlns:a="http://schemas.openxmlformats.org/drawingml/2006/main"/>
           <a:p xmlns:a="http://schemas.openxmlformats.org/drawingml/2006/main">
             <a:pPr algn="ctr">
+              <a:buNone/>
               <a:defRPr sz="1275" b="1">
                 <a:solidFill>
                   <a:srgbClr val="000000"/>
@@ -10975,6 +11106,7 @@
           <a:lstStyle xmlns:a="http://schemas.openxmlformats.org/drawingml/2006/main"/>
           <a:p xmlns:a="http://schemas.openxmlformats.org/drawingml/2006/main">
             <a:pPr algn="ctr">
+              <a:buNone/>
               <a:defRPr sz="1125" b="0">
                 <a:solidFill>
                   <a:srgbClr val="555B66"/>
@@ -11000,7 +11132,7 @@
       </p:sp>
       <p:cxnSp>
         <p:nvCxnSpPr>
-          <p:cNvPr id="43" name=""/>
+          <p:cNvPr id="62" name=""/>
           <p:cNvCxnSpPr/>
           <p:nvPr/>
         </p:nvCxnSpPr>
@@ -11119,6 +11251,7 @@
           <a:lstStyle xmlns:a="http://schemas.openxmlformats.org/drawingml/2006/main"/>
           <a:p xmlns:a="http://schemas.openxmlformats.org/drawingml/2006/main">
             <a:pPr algn="ctr">
+              <a:buNone/>
               <a:defRPr sz="1275" b="1">
                 <a:solidFill>
                   <a:srgbClr val="000000"/>
@@ -11177,6 +11310,7 @@
           <a:lstStyle xmlns:a="http://schemas.openxmlformats.org/drawingml/2006/main"/>
           <a:p xmlns:a="http://schemas.openxmlformats.org/drawingml/2006/main">
             <a:pPr algn="ctr">
+              <a:buNone/>
               <a:defRPr sz="1125" b="0">
                 <a:solidFill>
                   <a:srgbClr val="555B66"/>
@@ -11202,7 +11336,7 @@
       </p:sp>
       <p:cxnSp>
         <p:nvCxnSpPr>
-          <p:cNvPr id="48" name=""/>
+          <p:cNvPr id="67" name=""/>
           <p:cNvCxnSpPr/>
           <p:nvPr/>
         </p:nvCxnSpPr>
@@ -11321,6 +11455,7 @@
           <a:lstStyle xmlns:a="http://schemas.openxmlformats.org/drawingml/2006/main"/>
           <a:p xmlns:a="http://schemas.openxmlformats.org/drawingml/2006/main">
             <a:pPr algn="ctr">
+              <a:buNone/>
               <a:defRPr sz="1275" b="1">
                 <a:solidFill>
                   <a:srgbClr val="000000"/>
@@ -11379,6 +11514,7 @@
           <a:lstStyle xmlns:a="http://schemas.openxmlformats.org/drawingml/2006/main"/>
           <a:p xmlns:a="http://schemas.openxmlformats.org/drawingml/2006/main">
             <a:pPr algn="ctr">
+              <a:buNone/>
               <a:defRPr sz="1125" b="0">
                 <a:solidFill>
                   <a:srgbClr val="555B66"/>
@@ -11468,6 +11604,7 @@
           <a:lstStyle xmlns:a="http://schemas.openxmlformats.org/drawingml/2006/main"/>
           <a:p xmlns:a="http://schemas.openxmlformats.org/drawingml/2006/main">
             <a:pPr algn="l">
+              <a:buNone/>
               <a:defRPr sz="1350" b="1">
                 <a:solidFill>
                   <a:srgbClr val="000000"/>
@@ -11526,6 +11663,7 @@
           <a:lstStyle xmlns:a="http://schemas.openxmlformats.org/drawingml/2006/main"/>
           <a:p xmlns:a="http://schemas.openxmlformats.org/drawingml/2006/main">
             <a:pPr algn="l">
+              <a:buNone/>
               <a:defRPr sz="1350" b="0">
                 <a:solidFill>
                   <a:srgbClr val="555B66"/>
@@ -11544,7 +11682,7 @@
                 <a:ea typeface="Helvetica Neue"/>
                 <a:cs typeface="Helvetica Neue"/>
               </a:rPr>
-              <a:t>All trusted views finish; cancellation waits.</a:t>
+              <a:t>Cancellation waits; committed writes do not roll back.</a:t>
             </a:r>
           </a:p>
         </p:txBody>
@@ -11615,6 +11753,7 @@
           <a:lstStyle xmlns:a="http://schemas.openxmlformats.org/drawingml/2006/main"/>
           <a:p xmlns:a="http://schemas.openxmlformats.org/drawingml/2006/main">
             <a:pPr algn="l">
+              <a:buNone/>
               <a:defRPr sz="1350" b="1">
                 <a:solidFill>
                   <a:srgbClr val="000000"/>
@@ -11673,6 +11812,7 @@
           <a:lstStyle xmlns:a="http://schemas.openxmlformats.org/drawingml/2006/main"/>
           <a:p xmlns:a="http://schemas.openxmlformats.org/drawingml/2006/main">
             <a:pPr algn="l">
+              <a:buNone/>
               <a:defRPr sz="1350" b="0">
                 <a:solidFill>
                   <a:srgbClr val="555B66"/>
@@ -11760,6 +11900,7 @@
           <a:lstStyle xmlns:a="http://schemas.openxmlformats.org/drawingml/2006/main"/>
           <a:p xmlns:a="http://schemas.openxmlformats.org/drawingml/2006/main">
             <a:pPr algn="l">
+              <a:buNone/>
               <a:defRPr sz="1050" b="1">
                 <a:solidFill>
                   <a:srgbClr val="3D8DFF"/>
@@ -11818,6 +11959,7 @@
           <a:lstStyle xmlns:a="http://schemas.openxmlformats.org/drawingml/2006/main"/>
           <a:p xmlns:a="http://schemas.openxmlformats.org/drawingml/2006/main">
             <a:pPr algn="l">
+              <a:buNone/>
               <a:defRPr sz="3000" b="1">
                 <a:solidFill>
                   <a:srgbClr val="000000"/>
@@ -11876,6 +12018,7 @@
           <a:lstStyle xmlns:a="http://schemas.openxmlformats.org/drawingml/2006/main"/>
           <a:p xmlns:a="http://schemas.openxmlformats.org/drawingml/2006/main">
             <a:pPr algn="r">
+              <a:buNone/>
               <a:defRPr sz="975" b="0">
                 <a:solidFill>
                   <a:srgbClr val="555B66"/>
@@ -11965,6 +12108,7 @@
           <a:lstStyle xmlns:a="http://schemas.openxmlformats.org/drawingml/2006/main"/>
           <a:p xmlns:a="http://schemas.openxmlformats.org/drawingml/2006/main">
             <a:pPr algn="ctr">
+              <a:buNone/>
               <a:defRPr sz="1350" b="1">
                 <a:solidFill>
                   <a:srgbClr val="FFFFFF"/>
@@ -12023,6 +12167,7 @@
           <a:lstStyle xmlns:a="http://schemas.openxmlformats.org/drawingml/2006/main"/>
           <a:p xmlns:a="http://schemas.openxmlformats.org/drawingml/2006/main">
             <a:pPr algn="l">
+              <a:buNone/>
               <a:defRPr sz="2025" b="1">
                 <a:solidFill>
                   <a:srgbClr val="000000"/>
@@ -12081,6 +12226,7 @@
           <a:lstStyle xmlns:a="http://schemas.openxmlformats.org/drawingml/2006/main"/>
           <a:p xmlns:a="http://schemas.openxmlformats.org/drawingml/2006/main">
             <a:pPr algn="l">
+              <a:buNone/>
               <a:defRPr sz="1500" b="0">
                 <a:solidFill>
                   <a:srgbClr val="555B66"/>
@@ -12106,7 +12252,7 @@
       </p:sp>
       <p:cxnSp>
         <p:nvCxnSpPr>
-          <p:cNvPr id="31" name=""/>
+          <p:cNvPr id="45" name=""/>
           <p:cNvCxnSpPr/>
           <p:nvPr/>
         </p:nvCxnSpPr>
@@ -12223,6 +12369,7 @@
           <a:lstStyle xmlns:a="http://schemas.openxmlformats.org/drawingml/2006/main"/>
           <a:p xmlns:a="http://schemas.openxmlformats.org/drawingml/2006/main">
             <a:pPr algn="ctr">
+              <a:buNone/>
               <a:defRPr sz="1350" b="1">
                 <a:solidFill>
                   <a:srgbClr val="FFFFFF"/>
@@ -12281,6 +12428,7 @@
           <a:lstStyle xmlns:a="http://schemas.openxmlformats.org/drawingml/2006/main"/>
           <a:p xmlns:a="http://schemas.openxmlformats.org/drawingml/2006/main">
             <a:pPr algn="l">
+              <a:buNone/>
               <a:defRPr sz="2025" b="1">
                 <a:solidFill>
                   <a:srgbClr val="000000"/>
@@ -12339,6 +12487,7 @@
           <a:lstStyle xmlns:a="http://schemas.openxmlformats.org/drawingml/2006/main"/>
           <a:p xmlns:a="http://schemas.openxmlformats.org/drawingml/2006/main">
             <a:pPr algn="l">
+              <a:buNone/>
               <a:defRPr sz="1500" b="0">
                 <a:solidFill>
                   <a:srgbClr val="555B66"/>
@@ -12357,14 +12506,14 @@
                 <a:ea typeface="Helvetica Neue"/>
                 <a:cs typeface="Helvetica Neue"/>
               </a:rPr>
-              <a:t>Join wait_closed() or cancel(); repeated callers join the same finalizer.</a:t>
+              <a:t>Join wait_closed() or cancel(); then reap a pending local read.</a:t>
             </a:r>
           </a:p>
         </p:txBody>
       </p:sp>
       <p:cxnSp>
         <p:nvCxnSpPr>
-          <p:cNvPr id="37" name=""/>
+          <p:cNvPr id="51" name=""/>
           <p:cNvCxnSpPr/>
           <p:nvPr/>
         </p:nvCxnSpPr>
@@ -12481,6 +12630,7 @@
           <a:lstStyle xmlns:a="http://schemas.openxmlformats.org/drawingml/2006/main"/>
           <a:p xmlns:a="http://schemas.openxmlformats.org/drawingml/2006/main">
             <a:pPr algn="ctr">
+              <a:buNone/>
               <a:defRPr sz="1350" b="1">
                 <a:solidFill>
                   <a:srgbClr val="FFFFFF"/>
@@ -12539,6 +12689,7 @@
           <a:lstStyle xmlns:a="http://schemas.openxmlformats.org/drawingml/2006/main"/>
           <a:p xmlns:a="http://schemas.openxmlformats.org/drawingml/2006/main">
             <a:pPr algn="l">
+              <a:buNone/>
               <a:defRPr sz="2025" b="1">
                 <a:solidFill>
                   <a:srgbClr val="000000"/>
@@ -12597,6 +12748,7 @@
           <a:lstStyle xmlns:a="http://schemas.openxmlformats.org/drawingml/2006/main"/>
           <a:p xmlns:a="http://schemas.openxmlformats.org/drawingml/2006/main">
             <a:pPr algn="l">
+              <a:buNone/>
               <a:defRPr sz="1500" b="0">
                 <a:solidFill>
                   <a:srgbClr val="555B66"/>
@@ -12686,6 +12838,7 @@
           <a:lstStyle xmlns:a="http://schemas.openxmlformats.org/drawingml/2006/main"/>
           <a:p xmlns:a="http://schemas.openxmlformats.org/drawingml/2006/main">
             <a:pPr algn="l">
+              <a:buNone/>
               <a:defRPr sz="1350" b="1">
                 <a:solidFill>
                   <a:srgbClr val="000000"/>
@@ -12704,7 +12857,7 @@
                 <a:ea typeface="Helvetica Neue"/>
                 <a:cs typeface="Helvetica Neue"/>
               </a:rPr>
-              <a:t>CLEANUP PROMISE BREAKS?</a:t>
+              <a:t>AFTER CLEANUP RETURNS</a:t>
             </a:r>
           </a:p>
         </p:txBody>
@@ -12739,11 +12892,12 @@
         </p:spPr>
         <p:txBody>
           <a:bodyPr xmlns:a="http://schemas.openxmlformats.org/drawingml/2006/main" anchor="t">
-            <a:normAutofit fontScale="84091"/>
+            <a:normAutofit fontScale="100000"/>
           </a:bodyPr>
           <a:lstStyle xmlns:a="http://schemas.openxmlformats.org/drawingml/2006/main"/>
           <a:p xmlns:a="http://schemas.openxmlformats.org/drawingml/2006/main">
             <a:pPr algn="l">
+              <a:buNone/>
               <a:defRPr sz="1650" b="1">
                 <a:solidFill>
                   <a:srgbClr val="000000"/>
@@ -12762,7 +12916,7 @@
                 <a:ea typeface="Helvetica Neue"/>
                 <a:cs typeface="Helvetica Neue"/>
               </a:rPr>
-              <a:t>Emit one bounded provider_cleanup_failed diagnostic — then preserve the already-selected outcome.</a:t>
+              <a:t>Cancel and join the local read; a successful barrier stays authoritative.</a:t>
             </a:r>
           </a:p>
         </p:txBody>
@@ -12802,6 +12956,7 @@
           <a:lstStyle xmlns:a="http://schemas.openxmlformats.org/drawingml/2006/main"/>
           <a:p xmlns:a="http://schemas.openxmlformats.org/drawingml/2006/main">
             <a:pPr algn="l">
+              <a:buNone/>
               <a:defRPr sz="1275" b="0">
                 <a:solidFill>
                   <a:srgbClr val="555B66"/>
@@ -12820,7 +12975,7 @@
                 <a:ea typeface="Helvetica Neue"/>
                 <a:cs typeface="Helvetica Neue"/>
               </a:rPr>
-              <a:t>No raw exception text. No fabricated terminal. No outcome rewrite.</a:t>
+              <a:t>Exceptions warn. Cancellation-resistant iterators need process isolation.</a:t>
             </a:r>
           </a:p>
         </p:txBody>
@@ -12889,6 +13044,7 @@
           <a:lstStyle xmlns:a="http://schemas.openxmlformats.org/drawingml/2006/main"/>
           <a:p xmlns:a="http://schemas.openxmlformats.org/drawingml/2006/main">
             <a:pPr algn="l">
+              <a:buNone/>
               <a:defRPr sz="1050" b="1">
                 <a:solidFill>
                   <a:srgbClr val="3D8DFF"/>
@@ -12947,6 +13103,7 @@
           <a:lstStyle xmlns:a="http://schemas.openxmlformats.org/drawingml/2006/main"/>
           <a:p xmlns:a="http://schemas.openxmlformats.org/drawingml/2006/main">
             <a:pPr algn="l">
+              <a:buNone/>
               <a:defRPr sz="3000" b="1">
                 <a:solidFill>
                   <a:srgbClr val="000000"/>
@@ -13005,6 +13162,7 @@
           <a:lstStyle xmlns:a="http://schemas.openxmlformats.org/drawingml/2006/main"/>
           <a:p xmlns:a="http://schemas.openxmlformats.org/drawingml/2006/main">
             <a:pPr algn="r">
+              <a:buNone/>
               <a:defRPr sz="975" b="0">
                 <a:solidFill>
                   <a:srgbClr val="555B66"/>
@@ -13094,6 +13252,7 @@
           <a:lstStyle xmlns:a="http://schemas.openxmlformats.org/drawingml/2006/main"/>
           <a:p xmlns:a="http://schemas.openxmlformats.org/drawingml/2006/main">
             <a:pPr algn="ctr">
+              <a:buNone/>
               <a:defRPr sz="1650" b="1">
                 <a:solidFill>
                   <a:srgbClr val="000000"/>
@@ -13152,6 +13311,7 @@
           <a:lstStyle xmlns:a="http://schemas.openxmlformats.org/drawingml/2006/main"/>
           <a:p xmlns:a="http://schemas.openxmlformats.org/drawingml/2006/main">
             <a:pPr algn="l">
+              <a:buNone/>
               <a:defRPr sz="1350" b="1">
                 <a:solidFill>
                   <a:srgbClr val="3D8DFF"/>
@@ -13210,6 +13370,7 @@
           <a:lstStyle xmlns:a="http://schemas.openxmlformats.org/drawingml/2006/main"/>
           <a:p xmlns:a="http://schemas.openxmlformats.org/drawingml/2006/main">
             <a:pPr algn="l">
+              <a:buNone/>
               <a:defRPr sz="1350" b="1">
                 <a:solidFill>
                   <a:srgbClr val="000000"/>
@@ -13299,6 +13460,7 @@
           <a:lstStyle xmlns:a="http://schemas.openxmlformats.org/drawingml/2006/main"/>
           <a:p xmlns:a="http://schemas.openxmlformats.org/drawingml/2006/main">
             <a:pPr algn="ctr">
+              <a:buNone/>
               <a:defRPr sz="975" b="1">
                 <a:solidFill>
                   <a:srgbClr val="FFFFFF"/>
@@ -13357,6 +13519,7 @@
           <a:lstStyle xmlns:a="http://schemas.openxmlformats.org/drawingml/2006/main"/>
           <a:p xmlns:a="http://schemas.openxmlformats.org/drawingml/2006/main">
             <a:pPr algn="l">
+              <a:buNone/>
               <a:defRPr sz="1500" b="0">
                 <a:solidFill>
                   <a:srgbClr val="000000"/>
@@ -13446,6 +13609,7 @@
           <a:lstStyle xmlns:a="http://schemas.openxmlformats.org/drawingml/2006/main"/>
           <a:p xmlns:a="http://schemas.openxmlformats.org/drawingml/2006/main">
             <a:pPr algn="ctr">
+              <a:buNone/>
               <a:defRPr sz="975" b="1">
                 <a:solidFill>
                   <a:srgbClr val="FFFFFF"/>
@@ -13504,6 +13668,7 @@
           <a:lstStyle xmlns:a="http://schemas.openxmlformats.org/drawingml/2006/main"/>
           <a:p xmlns:a="http://schemas.openxmlformats.org/drawingml/2006/main">
             <a:pPr algn="l">
+              <a:buNone/>
               <a:defRPr sz="1500" b="0">
                 <a:solidFill>
                   <a:srgbClr val="000000"/>
@@ -13593,6 +13758,7 @@
           <a:lstStyle xmlns:a="http://schemas.openxmlformats.org/drawingml/2006/main"/>
           <a:p xmlns:a="http://schemas.openxmlformats.org/drawingml/2006/main">
             <a:pPr algn="ctr">
+              <a:buNone/>
               <a:defRPr sz="975" b="1">
                 <a:solidFill>
                   <a:srgbClr val="FFFFFF"/>
@@ -13651,6 +13817,7 @@
           <a:lstStyle xmlns:a="http://schemas.openxmlformats.org/drawingml/2006/main"/>
           <a:p xmlns:a="http://schemas.openxmlformats.org/drawingml/2006/main">
             <a:pPr algn="l">
+              <a:buNone/>
               <a:defRPr sz="1500" b="0">
                 <a:solidFill>
                   <a:srgbClr val="000000"/>
@@ -13740,6 +13907,7 @@
           <a:lstStyle xmlns:a="http://schemas.openxmlformats.org/drawingml/2006/main"/>
           <a:p xmlns:a="http://schemas.openxmlformats.org/drawingml/2006/main">
             <a:pPr algn="ctr">
+              <a:buNone/>
               <a:defRPr sz="975" b="1">
                 <a:solidFill>
                   <a:srgbClr val="FFFFFF"/>
@@ -13798,6 +13966,7 @@
           <a:lstStyle xmlns:a="http://schemas.openxmlformats.org/drawingml/2006/main"/>
           <a:p xmlns:a="http://schemas.openxmlformats.org/drawingml/2006/main">
             <a:pPr algn="l">
+              <a:buNone/>
               <a:defRPr sz="1500" b="0">
                 <a:solidFill>
                   <a:srgbClr val="000000"/>
@@ -13887,6 +14056,7 @@
           <a:lstStyle xmlns:a="http://schemas.openxmlformats.org/drawingml/2006/main"/>
           <a:p xmlns:a="http://schemas.openxmlformats.org/drawingml/2006/main">
             <a:pPr algn="ctr">
+              <a:buNone/>
               <a:defRPr sz="975" b="1">
                 <a:solidFill>
                   <a:srgbClr val="FFFFFF"/>
@@ -13945,6 +14115,7 @@
           <a:lstStyle xmlns:a="http://schemas.openxmlformats.org/drawingml/2006/main"/>
           <a:p xmlns:a="http://schemas.openxmlformats.org/drawingml/2006/main">
             <a:pPr algn="l">
+              <a:buNone/>
               <a:defRPr sz="1500" b="0">
                 <a:solidFill>
                   <a:srgbClr val="000000"/>
@@ -14034,6 +14205,7 @@
           <a:lstStyle xmlns:a="http://schemas.openxmlformats.org/drawingml/2006/main"/>
           <a:p xmlns:a="http://schemas.openxmlformats.org/drawingml/2006/main">
             <a:pPr algn="ctr">
+              <a:buNone/>
               <a:defRPr sz="975" b="1">
                 <a:solidFill>
                   <a:srgbClr val="FFFFFF"/>
@@ -14092,6 +14264,7 @@
           <a:lstStyle xmlns:a="http://schemas.openxmlformats.org/drawingml/2006/main"/>
           <a:p xmlns:a="http://schemas.openxmlformats.org/drawingml/2006/main">
             <a:pPr algn="l">
+              <a:buNone/>
               <a:defRPr sz="1500" b="0">
                 <a:solidFill>
                   <a:srgbClr val="000000"/>
@@ -14181,6 +14354,7 @@
           <a:lstStyle xmlns:a="http://schemas.openxmlformats.org/drawingml/2006/main"/>
           <a:p xmlns:a="http://schemas.openxmlformats.org/drawingml/2006/main">
             <a:pPr algn="ctr">
+              <a:buNone/>
               <a:defRPr sz="975" b="1">
                 <a:solidFill>
                   <a:srgbClr val="FFFFFF"/>
@@ -14239,6 +14413,7 @@
           <a:lstStyle xmlns:a="http://schemas.openxmlformats.org/drawingml/2006/main"/>
           <a:p xmlns:a="http://schemas.openxmlformats.org/drawingml/2006/main">
             <a:pPr algn="l">
+              <a:buNone/>
               <a:defRPr sz="1500" b="0">
                 <a:solidFill>
                   <a:srgbClr val="000000"/>
@@ -14328,6 +14503,7 @@
           <a:lstStyle xmlns:a="http://schemas.openxmlformats.org/drawingml/2006/main"/>
           <a:p xmlns:a="http://schemas.openxmlformats.org/drawingml/2006/main">
             <a:pPr algn="ctr">
+              <a:buNone/>
               <a:defRPr sz="975" b="1">
                 <a:solidFill>
                   <a:srgbClr val="FFFFFF"/>
@@ -14386,6 +14562,7 @@
           <a:lstStyle xmlns:a="http://schemas.openxmlformats.org/drawingml/2006/main"/>
           <a:p xmlns:a="http://schemas.openxmlformats.org/drawingml/2006/main">
             <a:pPr algn="l">
+              <a:buNone/>
               <a:defRPr sz="1500" b="0">
                 <a:solidFill>
                   <a:srgbClr val="000000"/>
@@ -14444,6 +14621,7 @@
           <a:lstStyle xmlns:a="http://schemas.openxmlformats.org/drawingml/2006/main"/>
           <a:p xmlns:a="http://schemas.openxmlformats.org/drawingml/2006/main">
             <a:pPr algn="l">
+              <a:buNone/>
               <a:defRPr sz="1500" b="1">
                 <a:solidFill>
                   <a:srgbClr val="000000"/>

</xml_diff>